<commit_message>
docs: problem statement is SIH26237, Ministry of Defence
The PS turned out to be Cryptographic Attribution and Immutable Decryption
Provenance for Multi-Recipient Encrypted Document Distribution, posted by the
Ministry of Defence -- which changes the framing, not just the header. The impact
slide now addresses service headquarters, defence procurement, DRDO and partner
sharing, and inter-agency circulation rather than generic ministries.

Deck also gains a QR to the running demo, a verdict panel showing what the system
actually returns (drawn natively -- the demo UI is dark and screenshots print
muddy), the compliance checklist reworded to mirror the PS's own twelve
requirements, and speaker notes on every slide.

Both sites now name the problem statement, so a judge landing on them knows which
one they answer.
</commit_message>
<xml_diff>
--- a/ppt/NOX_SIH2026_PQFW.pptx
+++ b/ppt/NOX_SIH2026_PQFW.pptx
@@ -643,14 +643,9 @@
           </a:bodyPr>
           <a:lstStyle/>
           <a:p>
-            <a:pPr eaLnBrk="1" hangingPunct="1">
-              <a:spcBef>
-                <a:spcPct val="0"/>
-              </a:spcBef>
-            </a:pPr>
-            <a:endParaRPr lang="en-US">
-              <a:ea typeface="ＭＳ Ｐゴシック" pitchFamily="1" charset="-128"/>
-            </a:endParaRPr>
+            <a:r>
+              <a:t>The core idea in one sentence: the fingerprint is a consequence of which decryption keys you hold, not of software choosing to add a watermark. Each mark slot is written two ways that look identical and encrypted under different keys; you get one key per slot. The other rendering is an AES-GCM tag failure for you. There is no unmarked copy anywhere — not even on our own disk. Bottom left is a real verdict from the running system.</a:t>
+            </a:r>
           </a:p>
         </p:txBody>
       </p:sp>
@@ -762,14 +757,9 @@
           </a:bodyPr>
           <a:lstStyle/>
           <a:p>
-            <a:pPr eaLnBrk="1" hangingPunct="1">
-              <a:spcBef>
-                <a:spcPct val="0"/>
-              </a:spcBef>
-            </a:pPr>
-            <a:endParaRPr lang="en-US">
-              <a:ea typeface="ＭＳ Ｐゴシック" pitchFamily="1" charset="-128"/>
-            </a:endParaRPr>
+            <a:r>
+              <a:t>Three stages, all offline. Distribute: one ciphertext for everybody, plus a 14 KB key bundle each. Decrypt: the recipient spends one credential, gets a uniquely marked copy, and signs an ML-DSA-65 receipt with their own key — that is the non-repudiation. Record: three validators independently verify that receipt and commit it 2-of-3. Trace: extract the marks, score them, and check the ledger. No cloud KMS, no public chain, no network call at any point.</a:t>
+            </a:r>
           </a:p>
         </p:txBody>
       </p:sp>
@@ -881,14 +871,9 @@
           </a:bodyPr>
           <a:lstStyle/>
           <a:p>
-            <a:pPr eaLnBrk="1" hangingPunct="1">
-              <a:spcBef>
-                <a:spcPct val="0"/>
-              </a:spcBef>
-            </a:pPr>
-            <a:endParaRPr lang="en-US">
-              <a:ea typeface="ＭＳ Ｐゴシック" pitchFamily="1" charset="-128"/>
-            </a:endParaRPr>
+            <a:r>
+              <a:t>We are honest about what breaks it. Retyping, OCR and stripping invisible characters defeat the text carrier, and inserting a word desynchronises the slots — all four are measured and published rather than hidden. The point is the failure mode: when an attack wins the system fails to identify anybody. Misidentification stayed at zero across the whole erasure sweep. The bottom row is the actual next four steps, not an aspiration.</a:t>
+            </a:r>
           </a:p>
         </p:txBody>
       </p:sp>
@@ -1059,14 +1044,9 @@
           </a:bodyPr>
           <a:lstStyle/>
           <a:p>
-            <a:pPr eaLnBrk="1" hangingPunct="1">
-              <a:spcBef>
-                <a:spcPct val="0"/>
-              </a:spcBef>
-            </a:pPr>
-            <a:endParaRPr lang="en-US">
-              <a:ea typeface="ＭＳ Ｐゴシック" pitchFamily="1" charset="-128"/>
-            </a:endParaRPr>
+            <a:r>
+              <a:t>Ministry of Defence context: service HQ, procurement, DRDO and partners, inter-agency sharing. The real product is deterrence — when every holder knows their copy is individually accountable, most leaks never happen. And it protects the accused as much as it exposes the leaker: a stated error probability and a refusal to guess are what stop an innocent officer being named. Costs nothing to run.</a:t>
+            </a:r>
           </a:p>
         </p:txBody>
       </p:sp>
@@ -1237,14 +1217,9 @@
           </a:bodyPr>
           <a:lstStyle/>
           <a:p>
-            <a:pPr eaLnBrk="1" hangingPunct="1">
-              <a:spcBef>
-                <a:spcPct val="0"/>
-              </a:spcBef>
-            </a:pPr>
-            <a:endParaRPr lang="en-US">
-              <a:ea typeface="ＭＳ Ｐゴシック" pitchFamily="1" charset="-128"/>
-            </a:endParaRPr>
+            <a:r>
+              <a:t>Every requirement in the problem statement, and every one is exercised by an automated test and by a step of the live demo — 163 tests. Two things we do not claim: this proves traceability, not unframeability, because the distributor knows the codewords; post-quantum asymmetric fingerprinting has no drop-in construction yet and we say so rather than pretending. Scan the code and try to break it.</a:t>
+            </a:r>
           </a:p>
         </p:txBody>
       </p:sp>
@@ -1344,6 +1319,76 @@
         <p14:creationId xmlns:p14="http://schemas.microsoft.com/office/powerpoint/2010/main" val="1908672725"/>
       </p:ext>
     </p:extLst>
+  </p:cSld>
+  <p:clrMapOvr>
+    <a:masterClrMapping/>
+  </p:clrMapOvr>
+</p:notes>
+</file>
+
+<file path=ppt/notesSlides/notesSlide6.xml><?xml version="1.0" encoding="utf-8"?>
+<p:notes xmlns:a="http://schemas.openxmlformats.org/drawingml/2006/main" xmlns:p="http://schemas.openxmlformats.org/presentationml/2006/main" xmlns:r="http://schemas.openxmlformats.org/officeDocument/2006/relationships">
+  <p:cSld>
+    <p:spTree>
+      <p:nvGrpSpPr>
+        <p:cNvPr id="1" name=""/>
+        <p:cNvGrpSpPr/>
+        <p:nvPr/>
+      </p:nvGrpSpPr>
+      <p:grpSpPr>
+        <a:xfrm>
+          <a:off x="0" y="0"/>
+          <a:ext cx="0" cy="0"/>
+          <a:chOff x="0" y="0"/>
+          <a:chExt cx="0" cy="0"/>
+        </a:xfrm>
+      </p:grpSpPr>
+      <p:sp>
+        <p:nvSpPr>
+          <p:cNvPr id="2" name="Slide Image Placeholder 1"/>
+          <p:cNvSpPr>
+            <a:spLocks noGrp="1"/>
+          </p:cNvSpPr>
+          <p:nvPr>
+            <p:ph type="sldImg" idx="2"/>
+          </p:nvPr>
+        </p:nvSpPr>
+        <p:spPr/>
+      </p:sp>
+      <p:sp>
+        <p:nvSpPr>
+          <p:cNvPr id="3" name="Notes Placeholder 2"/>
+          <p:cNvSpPr>
+            <a:spLocks noGrp="1"/>
+          </p:cNvSpPr>
+          <p:nvPr>
+            <p:ph type="body" idx="3" sz="quarter"/>
+          </p:nvPr>
+        </p:nvSpPr>
+        <p:spPr/>
+        <p:txBody>
+          <a:bodyPr/>
+          <a:lstStyle/>
+          <a:p>
+            <a:r>
+              <a:t>Problem statement SIH26237, Ministry of Defence. One document goes to many cleared recipients; it leaks; today every one of them is an equally plausible suspect. We built PQFW, and it is running right now at the address on this slide — scan the code and follow along.</a:t>
+            </a:r>
+          </a:p>
+        </p:txBody>
+      </p:sp>
+      <p:sp>
+        <p:nvSpPr>
+          <p:cNvPr id="4" name="Slide Number Placeholder 3"/>
+          <p:cNvSpPr>
+            <a:spLocks noGrp="1"/>
+          </p:cNvSpPr>
+          <p:nvPr>
+            <p:ph type="sldNum" idx="5" sz="quarter"/>
+          </p:nvPr>
+        </p:nvSpPr>
+        <p:spPr/>
+      </p:sp>
+    </p:spTree>
   </p:cSld>
   <p:clrMapOvr>
     <a:masterClrMapping/>
@@ -5679,7 +5724,7 @@
         </p:nvSpPr>
         <p:spPr>
           <a:xfrm>
-            <a:off x="384048" y="2212848"/>
+            <a:off x="384048" y="2157984"/>
             <a:ext cx="6035040" cy="3017520"/>
           </a:xfrm>
           <a:prstGeom prst="rect">
@@ -5717,7 +5762,7 @@
                 </a:solidFill>
                 <a:latin typeface="Calibri"/>
               </a:rPr>
-              <a:t>SIH26XXX</a:t>
+              <a:t>SIH26237</a:t>
             </a:r>
           </a:p>
           <a:p>
@@ -5745,7 +5790,7 @@
                 </a:solidFill>
                 <a:latin typeface="Calibri"/>
               </a:rPr>
-              <a:t>Forensic attribution of leaked documents in broadcast-encrypt, individually-decrypt distribution</a:t>
+              <a:t>Cryptographic Attribution and Immutable Decryption Provenance for Multi-Recipient Encrypted Document Distribution</a:t>
             </a:r>
           </a:p>
           <a:p>
@@ -5764,6 +5809,34 @@
                 </a:solidFill>
                 <a:latin typeface="Calibri"/>
               </a:rPr>
+              <a:t>Organisation  </a:t>
+            </a:r>
+            <a:r>
+              <a:rPr sz="1050" b="1">
+                <a:solidFill>
+                  <a:srgbClr val="1F3864"/>
+                </a:solidFill>
+                <a:latin typeface="Calibri"/>
+              </a:rPr>
+              <a:t>Ministry of Defence</a:t>
+            </a:r>
+          </a:p>
+          <a:p>
+            <a:pPr algn="l">
+              <a:spcBef>
+                <a:spcPts val="0"/>
+              </a:spcBef>
+              <a:spcAft>
+                <a:spcPts val="600"/>
+              </a:spcAft>
+            </a:pPr>
+            <a:r>
+              <a:rPr sz="1050" b="1">
+                <a:solidFill>
+                  <a:srgbClr val="5A677D"/>
+                </a:solidFill>
+                <a:latin typeface="Calibri"/>
+              </a:rPr>
               <a:t>Theme  </a:t>
             </a:r>
             <a:r>
@@ -5829,7 +5902,7 @@
                 </a:solidFill>
                 <a:latin typeface="Calibri"/>
               </a:rPr>
-              <a:t>TEAM-ID</a:t>
+              <a:t>—  (to be assigned on the portal)</a:t>
             </a:r>
           </a:p>
           <a:p>
@@ -5870,8 +5943,8 @@
         </p:nvSpPr>
         <p:spPr>
           <a:xfrm>
-            <a:off x="384048" y="5230368"/>
-            <a:ext cx="6035040" cy="932688"/>
+            <a:off x="384048" y="5047488"/>
+            <a:ext cx="6035040" cy="1115568"/>
           </a:xfrm>
           <a:prstGeom prst="roundRect">
             <a:avLst>
@@ -5910,16 +5983,40 @@
           </a:p>
         </p:txBody>
       </p:sp>
-      <p:sp>
-        <p:nvSpPr>
-          <p:cNvPr id="40" name="TextBox 39"/>
+      <p:pic>
+        <p:nvPicPr>
+          <p:cNvPr id="40" name="Picture 39" descr="qr_live.png"/>
+          <p:cNvPicPr>
+            <a:picLocks noChangeAspect="1"/>
+          </p:cNvPicPr>
+          <p:nvPr/>
+        </p:nvPicPr>
+        <p:blipFill>
+          <a:blip r:embed="rId4"/>
+          <a:stretch>
+            <a:fillRect/>
+          </a:stretch>
+        </p:blipFill>
+        <p:spPr>
+          <a:xfrm>
+            <a:off x="530352" y="5175504"/>
+            <a:ext cx="859536" cy="859536"/>
+          </a:xfrm>
+          <a:prstGeom prst="rect">
+            <a:avLst/>
+          </a:prstGeom>
+        </p:spPr>
+      </p:pic>
+      <p:sp>
+        <p:nvSpPr>
+          <p:cNvPr id="41" name="TextBox 40"/>
           <p:cNvSpPr txBox="1"/>
           <p:nvPr/>
         </p:nvSpPr>
         <p:spPr>
           <a:xfrm>
-            <a:off x="530352" y="5349240"/>
-            <a:ext cx="5760720" cy="731520"/>
+            <a:off x="1517904" y="5193792"/>
+            <a:ext cx="4754880" cy="841248"/>
           </a:xfrm>
           <a:prstGeom prst="rect">
             <a:avLst/>
@@ -5941,7 +6038,7 @@
               </a:spcAft>
             </a:pPr>
             <a:r>
-              <a:rPr sz="900" b="1">
+              <a:rPr sz="860" b="1">
                 <a:solidFill>
                   <a:srgbClr val="1B7F5E"/>
                 </a:solidFill>
@@ -5950,13 +6047,13 @@
               <a:t>LIVE WORKING PROTOTYPE   </a:t>
             </a:r>
             <a:r>
-              <a:rPr sz="900" b="0">
+              <a:rPr sz="860" b="0">
                 <a:solidFill>
                   <a:srgbClr val="5A677D"/>
                 </a:solidFill>
                 <a:latin typeface="Calibri"/>
               </a:rPr>
-              <a:t>·  real ML-KEM-768 / ML-DSA-65, in the browser</a:t>
+              <a:t>·  scan it</a:t>
             </a:r>
           </a:p>
           <a:p>
@@ -5965,11 +6062,11 @@
                 <a:spcPts val="0"/>
               </a:spcBef>
               <a:spcAft>
-                <a:spcPts val="100"/>
-              </a:spcAft>
-            </a:pPr>
-            <a:r>
-              <a:rPr sz="1250" b="1" i="0">
+                <a:spcPts val="200"/>
+              </a:spcAft>
+            </a:pPr>
+            <a:r>
+              <a:rPr sz="1300" b="1" i="0">
                 <a:solidFill>
                   <a:srgbClr val="1F3864"/>
                 </a:solidFill>
@@ -5988,20 +6085,20 @@
               </a:spcAft>
             </a:pPr>
             <a:r>
-              <a:rPr sz="740" b="0" i="0">
+              <a:rPr sz="720" b="0" i="0">
                 <a:solidFill>
                   <a:srgbClr val="5A677D"/>
                 </a:solidFill>
                 <a:latin typeface="Calibri"/>
               </a:rPr>
-              <a:t>Evaluation, figures and attack results:  evildeity-pqfw-post-quantum-watermarking.static.hf.space</a:t>
-            </a:r>
-          </a:p>
-        </p:txBody>
-      </p:sp>
-      <p:sp>
-        <p:nvSpPr>
-          <p:cNvPr id="41" name="TextBox 40"/>
+              <a:t>Real ML-KEM-768 / ML-DSA-65 computed server-side. Evaluation and attack results: evildeity-pqfw-post-quantum-watermarking.static.hf.space</a:t>
+            </a:r>
+          </a:p>
+        </p:txBody>
+      </p:sp>
+      <p:sp>
+        <p:nvSpPr>
+          <p:cNvPr id="42" name="TextBox 41"/>
           <p:cNvSpPr txBox="1"/>
           <p:nvPr/>
         </p:nvSpPr>
@@ -8006,7 +8103,7 @@
         </p:nvSpPr>
         <p:spPr>
           <a:xfrm>
-            <a:off x="384048" y="4864607"/>
+            <a:off x="384048" y="4791456"/>
             <a:ext cx="7223760" cy="274320"/>
           </a:xfrm>
           <a:prstGeom prst="rect">
@@ -8035,7 +8132,7 @@
                 </a:solidFill>
                 <a:latin typeface="Calibri"/>
               </a:rPr>
-              <a:t>What that looks like on one document</a:t>
+              <a:t>What the system actually returns</a:t>
             </a:r>
           </a:p>
         </p:txBody>
@@ -8048,20 +8145,20 @@
         </p:nvSpPr>
         <p:spPr>
           <a:xfrm>
-            <a:off x="384048" y="5157216"/>
-            <a:ext cx="7223760" cy="987552"/>
+            <a:off x="384048" y="5065776"/>
+            <a:ext cx="7223760" cy="1152144"/>
           </a:xfrm>
           <a:prstGeom prst="roundRect">
             <a:avLst>
-              <a:gd name="adj" fmla="val 5000"/>
+              <a:gd name="adj" fmla="val 6000"/>
             </a:avLst>
           </a:prstGeom>
           <a:solidFill>
-            <a:srgbClr val="FDF3E2"/>
+            <a:srgbClr val="E8F4EE"/>
           </a:solidFill>
           <a:ln w="9525">
             <a:solidFill>
-              <a:srgbClr val="E8C993"/>
+              <a:srgbClr val="A8D3BF"/>
             </a:solidFill>
           </a:ln>
           <a:effectLst/>
@@ -8096,8 +8193,8 @@
         </p:nvSpPr>
         <p:spPr>
           <a:xfrm>
-            <a:off x="530352" y="5257799"/>
-            <a:ext cx="6931152" cy="804672"/>
+            <a:off x="566928" y="5166360"/>
+            <a:ext cx="4114800" cy="457200"/>
           </a:xfrm>
           <a:prstGeom prst="rect">
             <a:avLst/>
@@ -8115,26 +8212,139 @@
                 <a:spcPts val="0"/>
               </a:spcBef>
               <a:spcAft>
-                <a:spcPts val="500"/>
-              </a:spcAft>
-            </a:pPr>
-            <a:r>
-              <a:rPr sz="940" b="1">
+                <a:spcPts val="200"/>
+              </a:spcAft>
+            </a:pPr>
+            <a:r>
+              <a:rPr sz="1300" b="1">
+                <a:solidFill>
+                  <a:srgbClr val="1B7F5E"/>
+                </a:solidFill>
+                <a:latin typeface="Calibri"/>
+              </a:rPr>
+              <a:t>IDENTIFIED</a:t>
+            </a:r>
+            <a:r>
+              <a:rPr sz="1300" b="1">
                 <a:solidFill>
                   <a:srgbClr val="1F3864"/>
                 </a:solidFill>
                 <a:latin typeface="Calibri"/>
               </a:rPr>
-              <a:t>A 2 KB memo, 20 recipients, 301 mark slots. </a:t>
-            </a:r>
-            <a:r>
-              <a:rPr sz="940" b="0">
+              <a:t>   r07, session #0</a:t>
+            </a:r>
+          </a:p>
+          <a:p>
+            <a:pPr algn="l">
+              <a:spcBef>
+                <a:spcPts val="0"/>
+              </a:spcBef>
+              <a:spcAft>
+                <a:spcPts val="0"/>
+              </a:spcAft>
+            </a:pPr>
+            <a:r>
+              <a:rPr sz="860" b="0" i="0">
+                <a:solidFill>
+                  <a:srgbClr val="5A677D"/>
+                </a:solidFill>
+                <a:latin typeface="Calibri"/>
+              </a:rPr>
+              <a:t>false-accusation probability at most 2.8 × 10⁻⁵⁹</a:t>
+            </a:r>
+          </a:p>
+        </p:txBody>
+      </p:sp>
+      <p:sp>
+        <p:nvSpPr>
+          <p:cNvPr id="15393" name="TextBox 15392"/>
+          <p:cNvSpPr txBox="1"/>
+          <p:nvPr/>
+        </p:nvSpPr>
+        <p:spPr>
+          <a:xfrm>
+            <a:off x="566928" y="5696712"/>
+            <a:ext cx="4114800" cy="274320"/>
+          </a:xfrm>
+          <a:prstGeom prst="rect">
+            <a:avLst/>
+          </a:prstGeom>
+          <a:noFill/>
+        </p:spPr>
+        <p:txBody>
+          <a:bodyPr wrap="square" anchor="t" lIns="0" rIns="0" tIns="0" bIns="0">
+            <a:spAutoFit/>
+          </a:bodyPr>
+          <a:lstStyle/>
+          <a:p/>
+          <a:p>
+            <a:pPr algn="l">
+              <a:spcBef>
+                <a:spcPts val="0"/>
+              </a:spcBef>
+              <a:spcAft>
+                <a:spcPts val="0"/>
+              </a:spcAft>
+            </a:pPr>
+            <a:r>
+              <a:rPr sz="780" b="0" i="0">
+                <a:solidFill>
+                  <a:srgbClr val="5A677D"/>
+                </a:solidFill>
+                <a:latin typeface="Calibri"/>
+              </a:rPr>
+              <a:t>2 KB memo · 20 recipients · 301 mark slots · next suspect 10σ behind</a:t>
+            </a:r>
+          </a:p>
+        </p:txBody>
+      </p:sp>
+      <p:sp>
+        <p:nvSpPr>
+          <p:cNvPr id="15394" name="TextBox 15393"/>
+          <p:cNvSpPr txBox="1"/>
+          <p:nvPr/>
+        </p:nvSpPr>
+        <p:spPr>
+          <a:xfrm>
+            <a:off x="4882896" y="5157216"/>
+            <a:ext cx="3017520" cy="1024128"/>
+          </a:xfrm>
+          <a:prstGeom prst="rect">
+            <a:avLst/>
+          </a:prstGeom>
+          <a:noFill/>
+        </p:spPr>
+        <p:txBody>
+          <a:bodyPr wrap="square" anchor="t" lIns="0" rIns="0" tIns="0" bIns="0">
+            <a:spAutoFit/>
+          </a:bodyPr>
+          <a:lstStyle/>
+          <a:p>
+            <a:pPr algn="l">
+              <a:spcBef>
+                <a:spcPts val="0"/>
+              </a:spcBef>
+              <a:spcAft>
+                <a:spcPts val="220"/>
+              </a:spcAft>
+            </a:pPr>
+            <a:r>
+              <a:rPr sz="780" b="1">
+                <a:solidFill>
+                  <a:srgbClr val="1B7F5E"/>
+                </a:solidFill>
+                <a:latin typeface="Calibri"/>
+              </a:rPr>
+              <a:t>✓  </a:t>
+            </a:r>
+            <a:r>
+              <a:rPr sz="780" b="0">
                 <a:solidFill>
                   <a:srgbClr val="202838"/>
                 </a:solidFill>
                 <a:latin typeface="Calibri"/>
               </a:rPr>
-              <a:t>r07 opens it once and signs an ML-DSA-65 receipt. Their copy leaks.</a:t>
+              <a:t>statistical significance (provable bound &lt; α)</a:t>
             </a:r>
           </a:p>
           <a:p>
@@ -8143,53 +8353,110 @@
                 <a:spcPts val="0"/>
               </a:spcBef>
               <a:spcAft>
-                <a:spcPts val="0"/>
-              </a:spcAft>
-            </a:pPr>
-            <a:r>
-              <a:rPr sz="940" b="0">
+                <a:spcPts val="220"/>
+              </a:spcAft>
+            </a:pPr>
+            <a:r>
+              <a:rPr sz="780" b="1">
+                <a:solidFill>
+                  <a:srgbClr val="1B7F5E"/>
+                </a:solidFill>
+                <a:latin typeface="Calibri"/>
+              </a:rPr>
+              <a:t>✓  </a:t>
+            </a:r>
+            <a:r>
+              <a:rPr sz="780" b="0">
                 <a:solidFill>
                   <a:srgbClr val="202838"/>
                 </a:solidFill>
                 <a:latin typeface="Calibri"/>
               </a:rPr>
-              <a:t>Traced back to </a:t>
-            </a:r>
-            <a:r>
-              <a:rPr sz="940" b="1">
-                <a:solidFill>
-                  <a:srgbClr val="1F3864"/>
-                </a:solidFill>
-                <a:latin typeface="Calibri"/>
-              </a:rPr>
-              <a:t>r07, session #0</a:t>
-            </a:r>
-            <a:r>
-              <a:rPr sz="940" b="0">
+              <a:t>the accused's own ML-DSA-65 receipt verifies</a:t>
+            </a:r>
+          </a:p>
+          <a:p>
+            <a:pPr algn="l">
+              <a:spcBef>
+                <a:spcPts val="0"/>
+              </a:spcBef>
+              <a:spcAft>
+                <a:spcPts val="220"/>
+              </a:spcAft>
+            </a:pPr>
+            <a:r>
+              <a:rPr sz="780" b="1">
+                <a:solidFill>
+                  <a:srgbClr val="1B7F5E"/>
+                </a:solidFill>
+                <a:latin typeface="Calibri"/>
+              </a:rPr>
+              <a:t>✓  </a:t>
+            </a:r>
+            <a:r>
+              <a:rPr sz="780" b="0">
                 <a:solidFill>
                   <a:srgbClr val="202838"/>
                 </a:solidFill>
                 <a:latin typeface="Calibri"/>
               </a:rPr>
-              <a:t> — with a provable false-accusation probability of </a:t>
-            </a:r>
-            <a:r>
-              <a:rPr sz="940" b="1">
+              <a:t>ledger hash chain intact</a:t>
+            </a:r>
+          </a:p>
+          <a:p>
+            <a:pPr algn="l">
+              <a:spcBef>
+                <a:spcPts val="0"/>
+              </a:spcBef>
+              <a:spcAft>
+                <a:spcPts val="220"/>
+              </a:spcAft>
+            </a:pPr>
+            <a:r>
+              <a:rPr sz="780" b="1">
                 <a:solidFill>
                   <a:srgbClr val="1B7F5E"/>
                 </a:solidFill>
                 <a:latin typeface="Calibri"/>
               </a:rPr>
-              <a:t>2.8 x 10⁻⁵⁹</a:t>
-            </a:r>
-            <a:r>
-              <a:rPr sz="940" b="0">
+              <a:t>✓  </a:t>
+            </a:r>
+            <a:r>
+              <a:rPr sz="780" b="0">
                 <a:solidFill>
                   <a:srgbClr val="202838"/>
                 </a:solidFill>
                 <a:latin typeface="Calibri"/>
               </a:rPr>
-              <a:t>, the next-best suspect 10 sigma behind, and all five ledger checks green.</a:t>
+              <a:t>block committed by 2 of 3 validators</a:t>
+            </a:r>
+          </a:p>
+          <a:p>
+            <a:pPr algn="l">
+              <a:spcBef>
+                <a:spcPts val="0"/>
+              </a:spcBef>
+              <a:spcAft>
+                <a:spcPts val="220"/>
+              </a:spcAft>
+            </a:pPr>
+            <a:r>
+              <a:rPr sz="780" b="1">
+                <a:solidFill>
+                  <a:srgbClr val="1B7F5E"/>
+                </a:solidFill>
+                <a:latin typeface="Calibri"/>
+              </a:rPr>
+              <a:t>✓  </a:t>
+            </a:r>
+            <a:r>
+              <a:rPr sz="780" b="0">
+                <a:solidFill>
+                  <a:srgbClr val="202838"/>
+                </a:solidFill>
+                <a:latin typeface="Calibri"/>
+              </a:rPr>
+              <a:t>Merkle inclusion proof to the signed root</a:t>
             </a:r>
           </a:p>
         </p:txBody>
@@ -14008,7 +14275,7 @@
                 </a:solidFill>
                 <a:latin typeface="Calibri"/>
               </a:rPr>
-              <a:t>Ministries and secretariats. </a:t>
+              <a:t>Service headquarters. </a:t>
             </a:r>
             <a:r>
               <a:rPr sz="919" b="0">
@@ -14017,7 +14284,7 @@
                 </a:solidFill>
                 <a:latin typeface="Calibri"/>
               </a:rPr>
-              <a:t>Cabinet notes, draft policy and pre-budget material become individually accountable.</a:t>
+              <a:t>Operational orders and classified assessments distributed to a named list become individually accountable, not collectively deniable.</a:t>
             </a:r>
           </a:p>
           <a:p>
@@ -14036,7 +14303,7 @@
                 </a:solidFill>
                 <a:latin typeface="Calibri"/>
               </a:rPr>
-              <a:t>Procurement and tendering. </a:t>
+              <a:t>Defence procurement. </a:t>
             </a:r>
             <a:r>
               <a:rPr sz="919" b="0">
@@ -14045,7 +14312,7 @@
                 </a:solidFill>
                 <a:latin typeface="Calibri"/>
               </a:rPr>
-              <a:t>Bid documents leak before deadlines; each copy now names its holder.</a:t>
+              <a:t>Tender documents and technical specifications reach vendors traceably; a pre-bid leak has an owner.</a:t>
             </a:r>
           </a:p>
           <a:p>
@@ -14064,7 +14331,7 @@
                 </a:solidFill>
                 <a:latin typeface="Calibri"/>
               </a:rPr>
-              <a:t>Examination boards. </a:t>
+              <a:t>DRDO and defence PSUs. </a:t>
             </a:r>
             <a:r>
               <a:rPr sz="919" b="0">
@@ -14073,7 +14340,7 @@
                 </a:solidFill>
                 <a:latin typeface="Calibri"/>
               </a:rPr>
-              <a:t>Question papers reach centres traceably, so a leak has an owner within minutes.</a:t>
+              <a:t>Design data shared with partners and contractors carries a non-repudiable receipt per recipient.</a:t>
             </a:r>
           </a:p>
           <a:p>
@@ -14092,7 +14359,7 @@
                 </a:solidFill>
                 <a:latin typeface="Calibri"/>
               </a:rPr>
-              <a:t>Courts and legal discovery. </a:t>
+              <a:t>Inter-agency sharing. </a:t>
             </a:r>
             <a:r>
               <a:rPr sz="919" b="0">
@@ -14101,7 +14368,7 @@
                 </a:solidFill>
                 <a:latin typeface="Calibri"/>
               </a:rPr>
-              <a:t>Material shared with opposing counsel carries non-repudiable receipts.</a:t>
+              <a:t>Intelligence circulated across agencies keeps its provenance without a central authority anyone must trust.</a:t>
             </a:r>
           </a:p>
         </p:txBody>
@@ -14242,7 +14509,7 @@
                 </a:solidFill>
                 <a:latin typeface="Calibri"/>
               </a:rPr>
-              <a:t>When 20 people know each copy is accountable, most of them do not leak at all.</a:t>
+              <a:t>When every holder knows their copy is individually accountable, most leaks never happen.</a:t>
             </a:r>
           </a:p>
           <a:p>
@@ -14326,7 +14593,7 @@
                 </a:solidFill>
                 <a:latin typeface="Calibri"/>
               </a:rPr>
-              <a:t>A cabinet note is sensitive for decades; FIPS 203/204 resist harvest-now-decrypt-later.</a:t>
+              <a:t>A defence assessment stays sensitive for decades; FIPS 203/204 resist harvest-now-decrypt-later.</a:t>
             </a:r>
           </a:p>
           <a:p>
@@ -14354,7 +14621,7 @@
                 </a:solidFill>
                 <a:latin typeface="Calibri"/>
               </a:rPr>
-              <a:t>Any ministry distributing one document to a named list — the architecture does not change, only the list.</a:t>
+              <a:t>Any organisation distributing one document to a named list — the architecture does not change, only the list.</a:t>
             </a:r>
           </a:p>
         </p:txBody>
@@ -14505,7 +14772,7 @@
                 </a:solidFill>
                 <a:latin typeface="Calibri"/>
               </a:rPr>
-              <a:t>▪  Every recipient who could decrypt is an equally plausible suspect.</a:t>
+              <a:t>▪  Every cleared recipient is an equally plausible suspect.</a:t>
             </a:r>
           </a:p>
           <a:p>
@@ -16159,7 +16426,7 @@
         </p:nvSpPr>
         <p:spPr>
           <a:xfrm>
-            <a:off x="384048" y="3877056"/>
+            <a:off x="384048" y="3840480"/>
             <a:ext cx="11420856" cy="274320"/>
           </a:xfrm>
           <a:prstGeom prst="rect">
@@ -16188,7 +16455,26 @@
                 </a:solidFill>
                 <a:latin typeface="Calibri"/>
               </a:rPr>
-              <a:t>Compliance with the problem statement</a:t>
+              <a:t>Every requirement in SIH26237, and where it is met</a:t>
+            </a:r>
+          </a:p>
+          <a:p>
+            <a:pPr algn="l">
+              <a:spcBef>
+                <a:spcPts val="0"/>
+              </a:spcBef>
+              <a:spcAft>
+                <a:spcPts val="0"/>
+              </a:spcAft>
+            </a:pPr>
+            <a:r>
+              <a:rPr sz="850" b="0" i="1">
+                <a:solidFill>
+                  <a:srgbClr val="5A677D"/>
+                </a:solidFill>
+                <a:latin typeface="Calibri"/>
+              </a:rPr>
+              <a:t>each one is exercised by an automated test, and by a step of the live demo</a:t>
             </a:r>
           </a:p>
         </p:txBody>
@@ -16201,7 +16487,7 @@
         </p:nvSpPr>
         <p:spPr>
           <a:xfrm>
-            <a:off x="384048" y="4206240"/>
+            <a:off x="384048" y="4224528"/>
             <a:ext cx="11420856" cy="1481328"/>
           </a:xfrm>
           <a:prstGeom prst="roundRect">
@@ -16249,8 +16535,8 @@
         </p:nvSpPr>
         <p:spPr>
           <a:xfrm>
-            <a:off x="566928" y="4334256"/>
-            <a:ext cx="5436108" cy="237744"/>
+            <a:off x="566928" y="4315968"/>
+            <a:ext cx="5436108" cy="219456"/>
           </a:xfrm>
           <a:prstGeom prst="rect">
             <a:avLst/>
@@ -16272,7 +16558,7 @@
               </a:spcAft>
             </a:pPr>
             <a:r>
-              <a:rPr sz="860" b="1">
+              <a:rPr sz="830" b="1">
                 <a:solidFill>
                   <a:srgbClr val="1B7F5E"/>
                 </a:solidFill>
@@ -16281,13 +16567,13 @@
               <a:t>✓  </a:t>
             </a:r>
             <a:r>
-              <a:rPr sz="860" b="0">
+              <a:rPr sz="830" b="0">
                 <a:solidFill>
                   <a:srgbClr val="202838"/>
                 </a:solidFill>
                 <a:latin typeface="Calibri"/>
               </a:rPr>
-              <a:t>Invisible watermark generated at decryption</a:t>
+              <a:t>Unique invisible forensic watermark at the moment of decryption</a:t>
             </a:r>
           </a:p>
         </p:txBody>
@@ -16300,8 +16586,8 @@
         </p:nvSpPr>
         <p:spPr>
           <a:xfrm>
-            <a:off x="566928" y="4590288"/>
-            <a:ext cx="5436108" cy="237744"/>
+            <a:off x="566928" y="4539996"/>
+            <a:ext cx="5436108" cy="219456"/>
           </a:xfrm>
           <a:prstGeom prst="rect">
             <a:avLst/>
@@ -16323,7 +16609,7 @@
               </a:spcAft>
             </a:pPr>
             <a:r>
-              <a:rPr sz="860" b="1">
+              <a:rPr sz="830" b="1">
                 <a:solidFill>
                   <a:srgbClr val="1B7F5E"/>
                 </a:solidFill>
@@ -16332,13 +16618,13 @@
               <a:t>✓  </a:t>
             </a:r>
             <a:r>
-              <a:rPr sz="860" b="0">
+              <a:rPr sz="830" b="0">
                 <a:solidFill>
                   <a:srgbClr val="202838"/>
                 </a:solidFill>
                 <a:latin typeface="Calibri"/>
               </a:rPr>
-              <a:t>Unique per recipient and per decryption session</a:t>
+              <a:t>Specific to each recipient and each decryption session</a:t>
             </a:r>
           </a:p>
         </p:txBody>
@@ -16351,8 +16637,8 @@
         </p:nvSpPr>
         <p:spPr>
           <a:xfrm>
-            <a:off x="566928" y="4846320"/>
-            <a:ext cx="5436108" cy="237744"/>
+            <a:off x="566928" y="4764024"/>
+            <a:ext cx="5436108" cy="219456"/>
           </a:xfrm>
           <a:prstGeom prst="rect">
             <a:avLst/>
@@ -16374,7 +16660,7 @@
               </a:spcAft>
             </a:pPr>
             <a:r>
-              <a:rPr sz="860" b="1">
+              <a:rPr sz="830" b="1">
                 <a:solidFill>
                   <a:srgbClr val="1B7F5E"/>
                 </a:solidFill>
@@ -16383,13 +16669,13 @@
               <a:t>✓  </a:t>
             </a:r>
             <a:r>
-              <a:rPr sz="860" b="0">
+              <a:rPr sz="830" b="0">
                 <a:solidFill>
                   <a:srgbClr val="202838"/>
                 </a:solidFill>
                 <a:latin typeface="Calibri"/>
               </a:rPr>
-              <a:t>Visually identical, forensically distinct</a:t>
+              <a:t>Every copy visually identical, forensically distinct</a:t>
             </a:r>
           </a:p>
         </p:txBody>
@@ -16402,8 +16688,8 @@
         </p:nvSpPr>
         <p:spPr>
           <a:xfrm>
-            <a:off x="566928" y="5102352"/>
-            <a:ext cx="5436108" cy="237744"/>
+            <a:off x="566928" y="4988052"/>
+            <a:ext cx="5436108" cy="219456"/>
           </a:xfrm>
           <a:prstGeom prst="rect">
             <a:avLst/>
@@ -16425,7 +16711,7 @@
               </a:spcAft>
             </a:pPr>
             <a:r>
-              <a:rPr sz="860" b="1">
+              <a:rPr sz="830" b="1">
                 <a:solidFill>
                   <a:srgbClr val="1B7F5E"/>
                 </a:solidFill>
@@ -16434,13 +16720,13 @@
               <a:t>✓  </a:t>
             </a:r>
             <a:r>
-              <a:rPr sz="860" b="0">
+              <a:rPr sz="830" b="0">
                 <a:solidFill>
                   <a:srgbClr val="202838"/>
                 </a:solidFill>
                 <a:latin typeface="Calibri"/>
               </a:rPr>
-              <a:t>Decryption bound to identity, signed with the recipient's own key</a:t>
+              <a:t>Each decryption cryptographically bound to the recipient's identity</a:t>
             </a:r>
           </a:p>
         </p:txBody>
@@ -16453,8 +16739,8 @@
         </p:nvSpPr>
         <p:spPr>
           <a:xfrm>
-            <a:off x="566928" y="5358384"/>
-            <a:ext cx="5436108" cy="237744"/>
+            <a:off x="566928" y="5212079"/>
+            <a:ext cx="5436108" cy="219456"/>
           </a:xfrm>
           <a:prstGeom prst="rect">
             <a:avLst/>
@@ -16476,7 +16762,7 @@
               </a:spcAft>
             </a:pPr>
             <a:r>
-              <a:rPr sz="860" b="1">
+              <a:rPr sz="830" b="1">
                 <a:solidFill>
                   <a:srgbClr val="1B7F5E"/>
                 </a:solidFill>
@@ -16485,13 +16771,13 @@
               <a:t>✓  </a:t>
             </a:r>
             <a:r>
-              <a:rPr sz="860" b="0">
+              <a:rPr sz="830" b="0">
                 <a:solidFill>
                   <a:srgbClr val="202838"/>
                 </a:solidFill>
                 <a:latin typeface="Calibri"/>
               </a:rPr>
-              <a:t>NIST post-quantum algorithms for key exchange and signature</a:t>
+              <a:t>Signature generated with the recipient's own private key</a:t>
             </a:r>
           </a:p>
         </p:txBody>
@@ -16504,8 +16790,8 @@
         </p:nvSpPr>
         <p:spPr>
           <a:xfrm>
-            <a:off x="6094476" y="4334256"/>
-            <a:ext cx="5436108" cy="237744"/>
+            <a:off x="566928" y="5436108"/>
+            <a:ext cx="5436108" cy="219456"/>
           </a:xfrm>
           <a:prstGeom prst="rect">
             <a:avLst/>
@@ -16527,7 +16813,7 @@
               </a:spcAft>
             </a:pPr>
             <a:r>
-              <a:rPr sz="860" b="1">
+              <a:rPr sz="830" b="1">
                 <a:solidFill>
                   <a:srgbClr val="1B7F5E"/>
                 </a:solidFill>
@@ -16536,13 +16822,13 @@
               <a:t>✓  </a:t>
             </a:r>
             <a:r>
-              <a:rPr sz="860" b="0">
+              <a:rPr sz="830" b="0">
                 <a:solidFill>
                   <a:srgbClr val="202838"/>
                 </a:solidFill>
                 <a:latin typeface="Calibri"/>
               </a:rPr>
-              <a:t>Immutable audit layer on a distributed ledger</a:t>
+              <a:t>NIST-standardised PQC for key exchange and digital signatures</a:t>
             </a:r>
           </a:p>
         </p:txBody>
@@ -16555,8 +16841,8 @@
         </p:nvSpPr>
         <p:spPr>
           <a:xfrm>
-            <a:off x="6094476" y="4590288"/>
-            <a:ext cx="5436108" cy="237744"/>
+            <a:off x="6094476" y="4315968"/>
+            <a:ext cx="5436108" cy="219456"/>
           </a:xfrm>
           <a:prstGeom prst="rect">
             <a:avLst/>
@@ -16578,7 +16864,7 @@
               </a:spcAft>
             </a:pPr>
             <a:r>
-              <a:rPr sz="860" b="1">
+              <a:rPr sz="830" b="1">
                 <a:solidFill>
                   <a:srgbClr val="1B7F5E"/>
                 </a:solidFill>
@@ -16587,13 +16873,13 @@
               <a:t>✓  </a:t>
             </a:r>
             <a:r>
-              <a:rPr sz="860" b="0">
+              <a:rPr sz="830" b="0">
                 <a:solidFill>
                   <a:srgbClr val="202838"/>
                 </a:solidFill>
                 <a:latin typeface="Calibri"/>
               </a:rPr>
-              <a:t>No single admin or compromised account can alter records</a:t>
+              <a:t>Immutable audit layer implemented as a distributed ledger</a:t>
             </a:r>
           </a:p>
         </p:txBody>
@@ -16606,8 +16892,8 @@
         </p:nvSpPr>
         <p:spPr>
           <a:xfrm>
-            <a:off x="6094476" y="4846320"/>
-            <a:ext cx="5436108" cy="237744"/>
+            <a:off x="6094476" y="4539996"/>
+            <a:ext cx="5436108" cy="219456"/>
           </a:xfrm>
           <a:prstGeom prst="rect">
             <a:avLst/>
@@ -16629,7 +16915,7 @@
               </a:spcAft>
             </a:pPr>
             <a:r>
-              <a:rPr sz="860" b="1">
+              <a:rPr sz="830" b="1">
                 <a:solidFill>
                   <a:srgbClr val="1B7F5E"/>
                 </a:solidFill>
@@ -16638,13 +16924,13 @@
               <a:t>✓  </a:t>
             </a:r>
             <a:r>
-              <a:rPr sz="860" b="0">
+              <a:rPr sz="830" b="0">
                 <a:solidFill>
                   <a:srgbClr val="202838"/>
                 </a:solidFill>
                 <a:latin typeface="Calibri"/>
               </a:rPr>
-              <a:t>Extract watermark, look up the ledger, return a verifiable record</a:t>
+              <a:t>No single administrator or compromised account can alter records</a:t>
             </a:r>
           </a:p>
         </p:txBody>
@@ -16657,8 +16943,8 @@
         </p:nvSpPr>
         <p:spPr>
           <a:xfrm>
-            <a:off x="6094476" y="5102352"/>
-            <a:ext cx="5436108" cy="237744"/>
+            <a:off x="6094476" y="4764024"/>
+            <a:ext cx="5436108" cy="219456"/>
           </a:xfrm>
           <a:prstGeom prst="rect">
             <a:avLst/>
@@ -16680,7 +16966,7 @@
               </a:spcAft>
             </a:pPr>
             <a:r>
-              <a:rPr sz="860" b="1">
+              <a:rPr sz="830" b="1">
                 <a:solidFill>
                   <a:srgbClr val="1B7F5E"/>
                 </a:solidFill>
@@ -16689,13 +16975,13 @@
               <a:t>✓  </a:t>
             </a:r>
             <a:r>
-              <a:rPr sz="860" b="0">
+              <a:rPr sz="830" b="0">
                 <a:solidFill>
                   <a:srgbClr val="202838"/>
                 </a:solidFill>
                 <a:latin typeface="Calibri"/>
               </a:rPr>
-              <a:t>Operates fully offline and air-gapped</a:t>
+              <a:t>Extract the watermark, match it against the ledger, verify it</a:t>
             </a:r>
           </a:p>
         </p:txBody>
@@ -16708,8 +16994,8 @@
         </p:nvSpPr>
         <p:spPr>
           <a:xfrm>
-            <a:off x="6094476" y="5358384"/>
-            <a:ext cx="5436108" cy="237744"/>
+            <a:off x="6094476" y="4988052"/>
+            <a:ext cx="5436108" cy="219456"/>
           </a:xfrm>
           <a:prstGeom prst="rect">
             <a:avLst/>
@@ -16731,7 +17017,7 @@
               </a:spcAft>
             </a:pPr>
             <a:r>
-              <a:rPr sz="860" b="1">
+              <a:rPr sz="830" b="1">
                 <a:solidFill>
                   <a:srgbClr val="1B7F5E"/>
                 </a:solidFill>
@@ -16740,13 +17026,115 @@
               <a:t>✓  </a:t>
             </a:r>
             <a:r>
-              <a:rPr sz="860" b="0">
+              <a:rPr sz="830" b="0">
                 <a:solidFill>
                   <a:srgbClr val="202838"/>
                 </a:solidFill>
                 <a:latin typeface="Calibri"/>
               </a:rPr>
-              <a:t>No cloud KMS and no public blockchain</a:t>
+              <a:t>Complete operation offline and air-gapped</a:t>
+            </a:r>
+          </a:p>
+        </p:txBody>
+      </p:sp>
+      <p:sp>
+        <p:nvSpPr>
+          <p:cNvPr id="17431" name="TextBox 17430"/>
+          <p:cNvSpPr txBox="1"/>
+          <p:nvPr/>
+        </p:nvSpPr>
+        <p:spPr>
+          <a:xfrm>
+            <a:off x="6094476" y="5212079"/>
+            <a:ext cx="5436108" cy="219456"/>
+          </a:xfrm>
+          <a:prstGeom prst="rect">
+            <a:avLst/>
+          </a:prstGeom>
+          <a:noFill/>
+        </p:spPr>
+        <p:txBody>
+          <a:bodyPr wrap="square" anchor="t" lIns="0" rIns="0" tIns="0" bIns="0">
+            <a:spAutoFit/>
+          </a:bodyPr>
+          <a:lstStyle/>
+          <a:p>
+            <a:pPr algn="l">
+              <a:spcBef>
+                <a:spcPts val="0"/>
+              </a:spcBef>
+              <a:spcAft>
+                <a:spcPts val="0"/>
+              </a:spcAft>
+            </a:pPr>
+            <a:r>
+              <a:rPr sz="830" b="1">
+                <a:solidFill>
+                  <a:srgbClr val="1B7F5E"/>
+                </a:solidFill>
+                <a:latin typeface="Calibri"/>
+              </a:rPr>
+              <a:t>✓  </a:t>
+            </a:r>
+            <a:r>
+              <a:rPr sz="830" b="0">
+                <a:solidFill>
+                  <a:srgbClr val="202838"/>
+                </a:solidFill>
+                <a:latin typeface="Calibri"/>
+              </a:rPr>
+              <a:t>No dependency on external cloud KMS services</a:t>
+            </a:r>
+          </a:p>
+        </p:txBody>
+      </p:sp>
+      <p:sp>
+        <p:nvSpPr>
+          <p:cNvPr id="17432" name="TextBox 17431"/>
+          <p:cNvSpPr txBox="1"/>
+          <p:nvPr/>
+        </p:nvSpPr>
+        <p:spPr>
+          <a:xfrm>
+            <a:off x="6094476" y="5436108"/>
+            <a:ext cx="5436108" cy="219456"/>
+          </a:xfrm>
+          <a:prstGeom prst="rect">
+            <a:avLst/>
+          </a:prstGeom>
+          <a:noFill/>
+        </p:spPr>
+        <p:txBody>
+          <a:bodyPr wrap="square" anchor="t" lIns="0" rIns="0" tIns="0" bIns="0">
+            <a:spAutoFit/>
+          </a:bodyPr>
+          <a:lstStyle/>
+          <a:p>
+            <a:pPr algn="l">
+              <a:spcBef>
+                <a:spcPts val="0"/>
+              </a:spcBef>
+              <a:spcAft>
+                <a:spcPts val="0"/>
+              </a:spcAft>
+            </a:pPr>
+            <a:r>
+              <a:rPr sz="830" b="1">
+                <a:solidFill>
+                  <a:srgbClr val="1B7F5E"/>
+                </a:solidFill>
+                <a:latin typeface="Calibri"/>
+              </a:rPr>
+              <a:t>✓  </a:t>
+            </a:r>
+            <a:r>
+              <a:rPr sz="830" b="0">
+                <a:solidFill>
+                  <a:srgbClr val="202838"/>
+                </a:solidFill>
+                <a:latin typeface="Calibri"/>
+              </a:rPr>
+              <a:t>No dependency on public blockchain networks</a:t>
             </a:r>
           </a:p>
         </p:txBody>

</xml_diff>

<commit_message>
fix(ppt): list content-anchored addressing on the technical slide
Slide 4 claims "Content-anchored slots. Shipped." while slide 3's stack table --
the place a judge looks for what the thing is built from -- still stopped at
"Carriers: zero-width space, PDF kerning". A differentiator the deck argues from
on one slide should be visible on the slide that lists the technology.

Co-Authored-By: Claude Opus 5 <noreply@anthropic.com>
</commit_message>
<xml_diff>
--- a/ppt/NOX_SIH2026_PQFW.pptx
+++ b/ppt/NOX_SIH2026_PQFW.pptx
@@ -13458,6 +13458,34 @@
               <a:t>zero-width space  ·  PDF kerning</a:t>
             </a:r>
           </a:p>
+          <a:p>
+            <a:pPr algn="l">
+              <a:spcBef>
+                <a:spcPts val="0"/>
+              </a:spcBef>
+              <a:spcAft>
+                <a:spcPts val="360"/>
+              </a:spcAft>
+            </a:pPr>
+            <a:r>
+              <a:rPr sz="860" b="1">
+                <a:solidFill>
+                  <a:srgbClr val="1B335E"/>
+                </a:solidFill>
+                <a:latin typeface="Calibri"/>
+              </a:rPr>
+              <a:t>Addressing   </a:t>
+            </a:r>
+            <a:r>
+              <a:rPr sz="860" b="0">
+                <a:solidFill>
+                  <a:srgbClr val="161D2B"/>
+                </a:solidFill>
+                <a:latin typeface="Calibri"/>
+              </a:rPr>
+              <a:t>content-anchored, SHA3-256</a:t>
+            </a:r>
+          </a:p>
         </p:txBody>
       </p:sp>
       <p:sp>

</xml_diff>